<commit_message>
Remove rounded subsection boxes in PowerPoint poster in favor of clean rectangular geometry
</commit_message>
<xml_diff>
--- a/pptx/Kolsky_Poster.pptx
+++ b/pptx/Kolsky_Poster.pptx
@@ -3133,7 +3133,7 @@
       </p:sp>
       <p:sp>
         <p:nvSpPr>
-          <p:cNvPr id="3" name="Rounded Rectangle 2"/>
+          <p:cNvPr id="3" name="Rectangle 2"/>
           <p:cNvSpPr/>
           <p:nvPr/>
         </p:nvSpPr>
@@ -3142,7 +3142,7 @@
             <a:off x="502920" y="320040"/>
             <a:ext cx="20939760" cy="3017520"/>
           </a:xfrm>
-          <a:prstGeom prst="roundRect">
+          <a:prstGeom prst="rect">
             <a:avLst/>
           </a:prstGeom>
           <a:solidFill>
@@ -3517,7 +3517,7 @@
       </p:sp>
       <p:sp>
         <p:nvSpPr>
-          <p:cNvPr id="11" name="Rounded Rectangle 10"/>
+          <p:cNvPr id="11" name="Rectangle 10"/>
           <p:cNvSpPr/>
           <p:nvPr/>
         </p:nvSpPr>
@@ -3526,7 +3526,7 @@
             <a:off x="502920" y="3520440"/>
             <a:ext cx="10287000" cy="7452360"/>
           </a:xfrm>
-          <a:prstGeom prst="roundRect">
+          <a:prstGeom prst="rect">
             <a:avLst/>
           </a:prstGeom>
           <a:solidFill>
@@ -3683,7 +3683,7 @@
       </p:sp>
       <p:sp>
         <p:nvSpPr>
-          <p:cNvPr id="15" name="Rounded Rectangle 14"/>
+          <p:cNvPr id="15" name="Rectangle 14"/>
           <p:cNvSpPr/>
           <p:nvPr/>
         </p:nvSpPr>
@@ -3692,7 +3692,7 @@
             <a:off x="8595360" y="3621024"/>
             <a:ext cx="2011680" cy="347472"/>
           </a:xfrm>
-          <a:prstGeom prst="roundRect">
+          <a:prstGeom prst="rect">
             <a:avLst/>
           </a:prstGeom>
           <a:solidFill>
@@ -3785,59 +3785,14 @@
       </p:pic>
       <p:sp>
         <p:nvSpPr>
-          <p:cNvPr id="18" name="Rounded Rectangle 17"/>
+          <p:cNvPr id="18" name="Rectangle 17"/>
           <p:cNvSpPr/>
           <p:nvPr/>
         </p:nvSpPr>
         <p:spPr>
           <a:xfrm>
             <a:off x="6099048" y="4206240"/>
-            <a:ext cx="4480560" cy="3108960"/>
-          </a:xfrm>
-          <a:prstGeom prst="roundRect">
-            <a:avLst/>
-          </a:prstGeom>
-          <a:solidFill>
-            <a:srgbClr val="F0F5FA"/>
-          </a:solidFill>
-          <a:ln w="12700">
-            <a:solidFill>
-              <a:srgbClr val="CBD5E1"/>
-            </a:solidFill>
-          </a:ln>
-        </p:spPr>
-        <p:style>
-          <a:lnRef idx="1">
-            <a:schemeClr val="accent1"/>
-          </a:lnRef>
-          <a:fillRef idx="3">
-            <a:schemeClr val="accent1"/>
-          </a:fillRef>
-          <a:effectRef idx="2">
-            <a:schemeClr val="accent1"/>
-          </a:effectRef>
-          <a:fontRef idx="minor">
-            <a:schemeClr val="lt1"/>
-          </a:fontRef>
-        </p:style>
-        <p:txBody>
-          <a:bodyPr rtlCol="0" anchor="ctr"/>
-          <a:lstStyle/>
-          <a:p>
-            <a:pPr algn="ctr"/>
-          </a:p>
-        </p:txBody>
-      </p:sp>
-      <p:sp>
-        <p:nvSpPr>
-          <p:cNvPr id="19" name="Rectangle 18"/>
-          <p:cNvSpPr/>
-          <p:nvPr/>
-        </p:nvSpPr>
-        <p:spPr>
-          <a:xfrm>
-            <a:off x="6099048" y="4206240"/>
-            <a:ext cx="4480560" cy="347472"/>
+            <a:ext cx="4480560" cy="329184"/>
           </a:xfrm>
           <a:prstGeom prst="rect">
             <a:avLst/>
@@ -3873,13 +3828,56 @@
       </p:sp>
       <p:sp>
         <p:nvSpPr>
+          <p:cNvPr id="19" name="Rectangle 18"/>
+          <p:cNvSpPr/>
+          <p:nvPr/>
+        </p:nvSpPr>
+        <p:spPr>
+          <a:xfrm>
+            <a:off x="6099048" y="4535424"/>
+            <a:ext cx="4480560" cy="27432"/>
+          </a:xfrm>
+          <a:prstGeom prst="rect">
+            <a:avLst/>
+          </a:prstGeom>
+          <a:solidFill>
+            <a:srgbClr val="D49B28"/>
+          </a:solidFill>
+          <a:ln>
+            <a:noFill/>
+          </a:ln>
+        </p:spPr>
+        <p:style>
+          <a:lnRef idx="1">
+            <a:schemeClr val="accent1"/>
+          </a:lnRef>
+          <a:fillRef idx="3">
+            <a:schemeClr val="accent1"/>
+          </a:fillRef>
+          <a:effectRef idx="2">
+            <a:schemeClr val="accent1"/>
+          </a:effectRef>
+          <a:fontRef idx="minor">
+            <a:schemeClr val="lt1"/>
+          </a:fontRef>
+        </p:style>
+        <p:txBody>
+          <a:bodyPr rtlCol="0" anchor="ctr"/>
+          <a:lstStyle/>
+          <a:p>
+            <a:pPr algn="ctr"/>
+          </a:p>
+        </p:txBody>
+      </p:sp>
+      <p:sp>
+        <p:nvSpPr>
           <p:cNvPr id="20" name="TextBox 19"/>
           <p:cNvSpPr txBox="1"/>
           <p:nvPr/>
         </p:nvSpPr>
         <p:spPr>
           <a:xfrm>
-            <a:off x="6099048" y="4242816"/>
+            <a:off x="6099048" y="4233672"/>
             <a:ext cx="4480560" cy="292608"/>
           </a:xfrm>
           <a:prstGeom prst="rect">
@@ -4290,7 +4288,7 @@
       </p:sp>
       <p:sp>
         <p:nvSpPr>
-          <p:cNvPr id="23" name="Rounded Rectangle 22"/>
+          <p:cNvPr id="23" name="Rectangle 22"/>
           <p:cNvSpPr/>
           <p:nvPr/>
         </p:nvSpPr>
@@ -4299,7 +4297,7 @@
             <a:off x="11155680" y="3520440"/>
             <a:ext cx="10287000" cy="7452360"/>
           </a:xfrm>
-          <a:prstGeom prst="roundRect">
+          <a:prstGeom prst="rect">
             <a:avLst/>
           </a:prstGeom>
           <a:solidFill>
@@ -4456,7 +4454,7 @@
       </p:sp>
       <p:sp>
         <p:nvSpPr>
-          <p:cNvPr id="27" name="Rounded Rectangle 26"/>
+          <p:cNvPr id="27" name="Rectangle 26"/>
           <p:cNvSpPr/>
           <p:nvPr/>
         </p:nvSpPr>
@@ -4465,7 +4463,7 @@
             <a:off x="19248120" y="3621024"/>
             <a:ext cx="2011680" cy="347472"/>
           </a:xfrm>
-          <a:prstGeom prst="roundRect">
+          <a:prstGeom prst="rect">
             <a:avLst/>
           </a:prstGeom>
           <a:solidFill>
@@ -4649,52 +4647,7 @@
       </p:sp>
       <p:sp>
         <p:nvSpPr>
-          <p:cNvPr id="31" name="Rounded Rectangle 30"/>
-          <p:cNvSpPr/>
-          <p:nvPr/>
-        </p:nvSpPr>
-        <p:spPr>
-          <a:xfrm>
-            <a:off x="11356848" y="7772400"/>
-            <a:ext cx="9884664" cy="3063240"/>
-          </a:xfrm>
-          <a:prstGeom prst="roundRect">
-            <a:avLst/>
-          </a:prstGeom>
-          <a:solidFill>
-            <a:srgbClr val="F0F5FA"/>
-          </a:solidFill>
-          <a:ln w="12700">
-            <a:solidFill>
-              <a:srgbClr val="CBD5E1"/>
-            </a:solidFill>
-          </a:ln>
-        </p:spPr>
-        <p:style>
-          <a:lnRef idx="1">
-            <a:schemeClr val="accent1"/>
-          </a:lnRef>
-          <a:fillRef idx="3">
-            <a:schemeClr val="accent1"/>
-          </a:fillRef>
-          <a:effectRef idx="2">
-            <a:schemeClr val="accent1"/>
-          </a:effectRef>
-          <a:fontRef idx="minor">
-            <a:schemeClr val="lt1"/>
-          </a:fontRef>
-        </p:style>
-        <p:txBody>
-          <a:bodyPr rtlCol="0" anchor="ctr"/>
-          <a:lstStyle/>
-          <a:p>
-            <a:pPr algn="ctr"/>
-          </a:p>
-        </p:txBody>
-      </p:sp>
-      <p:sp>
-        <p:nvSpPr>
-          <p:cNvPr id="32" name="Rectangle 31"/>
+          <p:cNvPr id="31" name="Rectangle 30"/>
           <p:cNvSpPr/>
           <p:nvPr/>
         </p:nvSpPr>
@@ -4737,6 +4690,49 @@
       </p:sp>
       <p:sp>
         <p:nvSpPr>
+          <p:cNvPr id="32" name="Rectangle 31"/>
+          <p:cNvSpPr/>
+          <p:nvPr/>
+        </p:nvSpPr>
+        <p:spPr>
+          <a:xfrm>
+            <a:off x="11356848" y="8101584"/>
+            <a:ext cx="9884664" cy="27432"/>
+          </a:xfrm>
+          <a:prstGeom prst="rect">
+            <a:avLst/>
+          </a:prstGeom>
+          <a:solidFill>
+            <a:srgbClr val="D49B28"/>
+          </a:solidFill>
+          <a:ln>
+            <a:noFill/>
+          </a:ln>
+        </p:spPr>
+        <p:style>
+          <a:lnRef idx="1">
+            <a:schemeClr val="accent1"/>
+          </a:lnRef>
+          <a:fillRef idx="3">
+            <a:schemeClr val="accent1"/>
+          </a:fillRef>
+          <a:effectRef idx="2">
+            <a:schemeClr val="accent1"/>
+          </a:effectRef>
+          <a:fontRef idx="minor">
+            <a:schemeClr val="lt1"/>
+          </a:fontRef>
+        </p:style>
+        <p:txBody>
+          <a:bodyPr rtlCol="0" anchor="ctr"/>
+          <a:lstStyle/>
+          <a:p>
+            <a:pPr algn="ctr"/>
+          </a:p>
+        </p:txBody>
+      </p:sp>
+      <p:sp>
+        <p:nvSpPr>
           <p:cNvPr id="33" name="TextBox 32"/>
           <p:cNvSpPr txBox="1"/>
           <p:nvPr/>
@@ -4771,7 +4767,7 @@
       </p:sp>
       <p:sp>
         <p:nvSpPr>
-          <p:cNvPr id="34" name="Rounded Rectangle 33"/>
+          <p:cNvPr id="34" name="Rectangle 33"/>
           <p:cNvSpPr/>
           <p:nvPr/>
         </p:nvSpPr>
@@ -4780,7 +4776,7 @@
             <a:off x="19366993" y="7818120"/>
             <a:ext cx="1783080" cy="237744"/>
           </a:xfrm>
-          <a:prstGeom prst="roundRect">
+          <a:prstGeom prst="rect">
             <a:avLst/>
           </a:prstGeom>
           <a:solidFill>
@@ -4964,7 +4960,7 @@
       </p:sp>
       <p:sp>
         <p:nvSpPr>
-          <p:cNvPr id="38" name="Rounded Rectangle 37"/>
+          <p:cNvPr id="38" name="Rectangle 37"/>
           <p:cNvSpPr/>
           <p:nvPr/>
         </p:nvSpPr>
@@ -4973,7 +4969,7 @@
             <a:off x="502920" y="11137392"/>
             <a:ext cx="20939760" cy="1188720"/>
           </a:xfrm>
-          <a:prstGeom prst="roundRect">
+          <a:prstGeom prst="rect">
             <a:avLst/>
           </a:prstGeom>
           <a:solidFill>
@@ -5052,7 +5048,7 @@
       </p:sp>
       <p:sp>
         <p:nvSpPr>
-          <p:cNvPr id="40" name="Rounded Rectangle 39"/>
+          <p:cNvPr id="40" name="Rectangle 39"/>
           <p:cNvSpPr/>
           <p:nvPr/>
         </p:nvSpPr>
@@ -5061,7 +5057,7 @@
             <a:off x="822960" y="11274552"/>
             <a:ext cx="4617720" cy="914400"/>
           </a:xfrm>
-          <a:prstGeom prst="roundRect">
+          <a:prstGeom prst="rect">
             <a:avLst/>
           </a:prstGeom>
           <a:solidFill>
@@ -5181,7 +5177,7 @@
       </p:sp>
       <p:sp>
         <p:nvSpPr>
-          <p:cNvPr id="43" name="Rounded Rectangle 42"/>
+          <p:cNvPr id="43" name="Rectangle 42"/>
           <p:cNvSpPr/>
           <p:nvPr/>
         </p:nvSpPr>
@@ -5190,7 +5186,7 @@
             <a:off x="5897880" y="11274552"/>
             <a:ext cx="4617720" cy="914400"/>
           </a:xfrm>
-          <a:prstGeom prst="roundRect">
+          <a:prstGeom prst="rect">
             <a:avLst/>
           </a:prstGeom>
           <a:solidFill>
@@ -5310,7 +5306,7 @@
       </p:sp>
       <p:sp>
         <p:nvSpPr>
-          <p:cNvPr id="46" name="Rounded Rectangle 45"/>
+          <p:cNvPr id="46" name="Rectangle 45"/>
           <p:cNvSpPr/>
           <p:nvPr/>
         </p:nvSpPr>
@@ -5319,7 +5315,7 @@
             <a:off x="10972800" y="11274552"/>
             <a:ext cx="4617720" cy="914400"/>
           </a:xfrm>
-          <a:prstGeom prst="roundRect">
+          <a:prstGeom prst="rect">
             <a:avLst/>
           </a:prstGeom>
           <a:solidFill>
@@ -5439,7 +5435,7 @@
       </p:sp>
       <p:sp>
         <p:nvSpPr>
-          <p:cNvPr id="49" name="Rounded Rectangle 48"/>
+          <p:cNvPr id="49" name="Rectangle 48"/>
           <p:cNvSpPr/>
           <p:nvPr/>
         </p:nvSpPr>
@@ -5448,7 +5444,7 @@
             <a:off x="16047720" y="11274552"/>
             <a:ext cx="4617720" cy="914400"/>
           </a:xfrm>
-          <a:prstGeom prst="roundRect">
+          <a:prstGeom prst="rect">
             <a:avLst/>
           </a:prstGeom>
           <a:solidFill>
@@ -5533,7 +5529,7 @@
       </p:sp>
       <p:sp>
         <p:nvSpPr>
-          <p:cNvPr id="51" name="Rounded Rectangle 50"/>
+          <p:cNvPr id="51" name="Rectangle 50"/>
           <p:cNvSpPr/>
           <p:nvPr/>
         </p:nvSpPr>
@@ -5542,7 +5538,7 @@
             <a:off x="502920" y="12481560"/>
             <a:ext cx="10287000" cy="7680960"/>
           </a:xfrm>
-          <a:prstGeom prst="roundRect">
+          <a:prstGeom prst="rect">
             <a:avLst/>
           </a:prstGeom>
           <a:solidFill>
@@ -5699,7 +5695,7 @@
       </p:sp>
       <p:sp>
         <p:nvSpPr>
-          <p:cNvPr id="55" name="Rounded Rectangle 54"/>
+          <p:cNvPr id="55" name="Rectangle 54"/>
           <p:cNvSpPr/>
           <p:nvPr/>
         </p:nvSpPr>
@@ -5708,7 +5704,7 @@
             <a:off x="8595360" y="12582144"/>
             <a:ext cx="2011680" cy="347472"/>
           </a:xfrm>
-          <a:prstGeom prst="roundRect">
+          <a:prstGeom prst="rect">
             <a:avLst/>
           </a:prstGeom>
           <a:solidFill>
@@ -5984,7 +5980,7 @@
       </p:sp>
       <p:sp>
         <p:nvSpPr>
-          <p:cNvPr id="60" name="Rounded Rectangle 59"/>
+          <p:cNvPr id="60" name="Rectangle 59"/>
           <p:cNvSpPr/>
           <p:nvPr/>
         </p:nvSpPr>
@@ -5993,7 +5989,7 @@
             <a:off x="11155680" y="12481560"/>
             <a:ext cx="10287000" cy="7680960"/>
           </a:xfrm>
-          <a:prstGeom prst="roundRect">
+          <a:prstGeom prst="rect">
             <a:avLst/>
           </a:prstGeom>
           <a:solidFill>
@@ -6150,7 +6146,7 @@
       </p:sp>
       <p:sp>
         <p:nvSpPr>
-          <p:cNvPr id="64" name="Rounded Rectangle 63"/>
+          <p:cNvPr id="64" name="Rectangle 63"/>
           <p:cNvSpPr/>
           <p:nvPr/>
         </p:nvSpPr>
@@ -6159,7 +6155,7 @@
             <a:off x="19248120" y="12582144"/>
             <a:ext cx="2011680" cy="347472"/>
           </a:xfrm>
-          <a:prstGeom prst="roundRect">
+          <a:prstGeom prst="rect">
             <a:avLst/>
           </a:prstGeom>
           <a:solidFill>
@@ -6369,25 +6365,23 @@
       </p:sp>
       <p:sp>
         <p:nvSpPr>
-          <p:cNvPr id="68" name="Rounded Rectangle 67"/>
+          <p:cNvPr id="68" name="Rectangle 67"/>
           <p:cNvSpPr/>
           <p:nvPr/>
         </p:nvSpPr>
         <p:spPr>
           <a:xfrm>
             <a:off x="11356848" y="15224760"/>
-            <a:ext cx="9884664" cy="2240280"/>
-          </a:xfrm>
-          <a:prstGeom prst="roundRect">
+            <a:ext cx="9884664" cy="292608"/>
+          </a:xfrm>
+          <a:prstGeom prst="rect">
             <a:avLst/>
           </a:prstGeom>
           <a:solidFill>
-            <a:srgbClr val="F0F5FA"/>
+            <a:srgbClr val="1F4E8C"/>
           </a:solidFill>
-          <a:ln w="12700">
-            <a:solidFill>
-              <a:srgbClr val="CBD5E1"/>
-            </a:solidFill>
+          <a:ln>
+            <a:noFill/>
           </a:ln>
         </p:spPr>
         <p:style>
@@ -6414,14 +6408,57 @@
       </p:sp>
       <p:sp>
         <p:nvSpPr>
-          <p:cNvPr id="69" name="TextBox 68"/>
+          <p:cNvPr id="69" name="Rectangle 68"/>
+          <p:cNvSpPr/>
+          <p:nvPr/>
+        </p:nvSpPr>
+        <p:spPr>
+          <a:xfrm>
+            <a:off x="11356848" y="15517368"/>
+            <a:ext cx="9884664" cy="27432"/>
+          </a:xfrm>
+          <a:prstGeom prst="rect">
+            <a:avLst/>
+          </a:prstGeom>
+          <a:solidFill>
+            <a:srgbClr val="D49B28"/>
+          </a:solidFill>
+          <a:ln>
+            <a:noFill/>
+          </a:ln>
+        </p:spPr>
+        <p:style>
+          <a:lnRef idx="1">
+            <a:schemeClr val="accent1"/>
+          </a:lnRef>
+          <a:fillRef idx="3">
+            <a:schemeClr val="accent1"/>
+          </a:fillRef>
+          <a:effectRef idx="2">
+            <a:schemeClr val="accent1"/>
+          </a:effectRef>
+          <a:fontRef idx="minor">
+            <a:schemeClr val="lt1"/>
+          </a:fontRef>
+        </p:style>
+        <p:txBody>
+          <a:bodyPr rtlCol="0" anchor="ctr"/>
+          <a:lstStyle/>
+          <a:p>
+            <a:pPr algn="ctr"/>
+          </a:p>
+        </p:txBody>
+      </p:sp>
+      <p:sp>
+        <p:nvSpPr>
+          <p:cNvPr id="70" name="TextBox 69"/>
           <p:cNvSpPr txBox="1"/>
           <p:nvPr/>
         </p:nvSpPr>
         <p:spPr>
           <a:xfrm>
-            <a:off x="11356848" y="15261336"/>
-            <a:ext cx="9884664" cy="274320"/>
+            <a:off x="11356848" y="15243048"/>
+            <a:ext cx="9884664" cy="256032"/>
           </a:xfrm>
           <a:prstGeom prst="rect">
             <a:avLst/>
@@ -6436,20 +6473,20 @@
           <a:p>
             <a:pPr algn="ctr"/>
             <a:r>
-              <a:rPr sz="880" b="1">
-                <a:solidFill>
-                  <a:srgbClr val="1F4E8C"/>
-                </a:solidFill>
-                <a:latin typeface="Arial"/>
-              </a:rPr>
-              <a:t>High-Speed Dynamic Compression Sequence (ε̇ ~ 4000 s⁻¹ OFHC Copper on Ø 3.17 mm Bars)</a:t>
+              <a:rPr sz="850" b="1">
+                <a:solidFill>
+                  <a:srgbClr val="FFFFFF"/>
+                </a:solidFill>
+                <a:latin typeface="Arial"/>
+              </a:rPr>
+              <a:t>HIGH-SPEED DYNAMIC COMPRESSION SEQUENCE (ε̇ ~ 4000 s⁻¹ OFHC COPPER ON Ø 3.17 mm BARS)</a:t>
             </a:r>
           </a:p>
         </p:txBody>
       </p:sp>
       <p:pic>
         <p:nvPicPr>
-          <p:cNvPr id="70" name="Picture 69" descr="copper_f1.png"/>
+          <p:cNvPr id="71" name="Picture 70" descr="copper_f1.png"/>
           <p:cNvPicPr>
             <a:picLocks noChangeAspect="1"/>
           </p:cNvPicPr>
@@ -6473,7 +6510,7 @@
       </p:pic>
       <p:sp>
         <p:nvSpPr>
-          <p:cNvPr id="71" name="TextBox 70"/>
+          <p:cNvPr id="72" name="TextBox 71"/>
           <p:cNvSpPr txBox="1"/>
           <p:nvPr/>
         </p:nvSpPr>
@@ -6517,7 +6554,7 @@
       </p:sp>
       <p:pic>
         <p:nvPicPr>
-          <p:cNvPr id="72" name="Picture 71" descr="copper_f2.png"/>
+          <p:cNvPr id="73" name="Picture 72" descr="copper_f2.png"/>
           <p:cNvPicPr>
             <a:picLocks noChangeAspect="1"/>
           </p:cNvPicPr>
@@ -6541,7 +6578,7 @@
       </p:pic>
       <p:sp>
         <p:nvSpPr>
-          <p:cNvPr id="73" name="TextBox 72"/>
+          <p:cNvPr id="74" name="TextBox 73"/>
           <p:cNvSpPr txBox="1"/>
           <p:nvPr/>
         </p:nvSpPr>
@@ -6585,7 +6622,7 @@
       </p:sp>
       <p:pic>
         <p:nvPicPr>
-          <p:cNvPr id="74" name="Picture 73" descr="copper_f3.png"/>
+          <p:cNvPr id="75" name="Picture 74" descr="copper_f3.png"/>
           <p:cNvPicPr>
             <a:picLocks noChangeAspect="1"/>
           </p:cNvPicPr>
@@ -6609,7 +6646,7 @@
       </p:pic>
       <p:sp>
         <p:nvSpPr>
-          <p:cNvPr id="75" name="TextBox 74"/>
+          <p:cNvPr id="76" name="TextBox 75"/>
           <p:cNvSpPr txBox="1"/>
           <p:nvPr/>
         </p:nvSpPr>
@@ -6653,7 +6690,7 @@
       </p:sp>
       <p:pic>
         <p:nvPicPr>
-          <p:cNvPr id="76" name="Picture 75" descr="copper_f4.png"/>
+          <p:cNvPr id="77" name="Picture 76" descr="copper_f4.png"/>
           <p:cNvPicPr>
             <a:picLocks noChangeAspect="1"/>
           </p:cNvPicPr>
@@ -6677,7 +6714,7 @@
       </p:pic>
       <p:sp>
         <p:nvSpPr>
-          <p:cNvPr id="77" name="TextBox 76"/>
+          <p:cNvPr id="78" name="TextBox 77"/>
           <p:cNvSpPr txBox="1"/>
           <p:nvPr/>
         </p:nvSpPr>
@@ -6721,7 +6758,7 @@
       </p:sp>
       <p:pic>
         <p:nvPicPr>
-          <p:cNvPr id="78" name="Picture 77" descr="copper_f5.png"/>
+          <p:cNvPr id="79" name="Picture 78" descr="copper_f5.png"/>
           <p:cNvPicPr>
             <a:picLocks noChangeAspect="1"/>
           </p:cNvPicPr>
@@ -6745,7 +6782,7 @@
       </p:pic>
       <p:sp>
         <p:nvSpPr>
-          <p:cNvPr id="79" name="TextBox 78"/>
+          <p:cNvPr id="80" name="TextBox 79"/>
           <p:cNvSpPr txBox="1"/>
           <p:nvPr/>
         </p:nvSpPr>
@@ -6789,7 +6826,7 @@
       </p:sp>
       <p:sp>
         <p:nvSpPr>
-          <p:cNvPr id="80" name="TextBox 79"/>
+          <p:cNvPr id="81" name="TextBox 80"/>
           <p:cNvSpPr txBox="1"/>
           <p:nvPr/>
         </p:nvSpPr>
@@ -6914,7 +6951,7 @@
       </p:sp>
       <p:sp>
         <p:nvSpPr>
-          <p:cNvPr id="81" name="Rounded Rectangle 80"/>
+          <p:cNvPr id="82" name="Rectangle 81"/>
           <p:cNvSpPr/>
           <p:nvPr/>
         </p:nvSpPr>
@@ -6923,7 +6960,7 @@
             <a:off x="502920" y="20345400"/>
             <a:ext cx="10287000" cy="8412480"/>
           </a:xfrm>
-          <a:prstGeom prst="roundRect">
+          <a:prstGeom prst="rect">
             <a:avLst/>
           </a:prstGeom>
           <a:solidFill>
@@ -6959,7 +6996,7 @@
       </p:sp>
       <p:sp>
         <p:nvSpPr>
-          <p:cNvPr id="82" name="Rectangle 81"/>
+          <p:cNvPr id="83" name="Rectangle 82"/>
           <p:cNvSpPr/>
           <p:nvPr/>
         </p:nvSpPr>
@@ -7002,7 +7039,7 @@
       </p:sp>
       <p:sp>
         <p:nvSpPr>
-          <p:cNvPr id="83" name="Rectangle 82"/>
+          <p:cNvPr id="84" name="Rectangle 83"/>
           <p:cNvSpPr/>
           <p:nvPr/>
         </p:nvSpPr>
@@ -7045,7 +7082,7 @@
       </p:sp>
       <p:sp>
         <p:nvSpPr>
-          <p:cNvPr id="84" name="TextBox 83"/>
+          <p:cNvPr id="85" name="TextBox 84"/>
           <p:cNvSpPr txBox="1"/>
           <p:nvPr/>
         </p:nvSpPr>
@@ -7080,7 +7117,7 @@
       </p:sp>
       <p:sp>
         <p:nvSpPr>
-          <p:cNvPr id="85" name="Rounded Rectangle 84"/>
+          <p:cNvPr id="86" name="Rectangle 85"/>
           <p:cNvSpPr/>
           <p:nvPr/>
         </p:nvSpPr>
@@ -7089,7 +7126,7 @@
             <a:off x="8595360" y="20445984"/>
             <a:ext cx="2011680" cy="347472"/>
           </a:xfrm>
-          <a:prstGeom prst="roundRect">
+          <a:prstGeom prst="rect">
             <a:avLst/>
           </a:prstGeom>
           <a:solidFill>
@@ -7123,7 +7160,7 @@
       </p:sp>
       <p:sp>
         <p:nvSpPr>
-          <p:cNvPr id="86" name="TextBox 85"/>
+          <p:cNvPr id="87" name="TextBox 86"/>
           <p:cNvSpPr txBox="1"/>
           <p:nvPr/>
         </p:nvSpPr>
@@ -7158,7 +7195,7 @@
       </p:sp>
       <p:pic>
         <p:nvPicPr>
-          <p:cNvPr id="87" name="Picture 86" descr="rate_and_damage_composite.png"/>
+          <p:cNvPr id="88" name="Picture 87" descr="rate_and_damage_composite.png"/>
           <p:cNvPicPr>
             <a:picLocks noChangeAspect="1"/>
           </p:cNvPicPr>
@@ -7182,7 +7219,7 @@
       </p:pic>
       <p:sp>
         <p:nvSpPr>
-          <p:cNvPr id="88" name="TextBox 87"/>
+          <p:cNvPr id="89" name="TextBox 88"/>
           <p:cNvSpPr txBox="1"/>
           <p:nvPr/>
         </p:nvSpPr>
@@ -7341,7 +7378,7 @@
       </p:sp>
       <p:sp>
         <p:nvSpPr>
-          <p:cNvPr id="89" name="Rounded Rectangle 88"/>
+          <p:cNvPr id="90" name="Rectangle 89"/>
           <p:cNvSpPr/>
           <p:nvPr/>
         </p:nvSpPr>
@@ -7350,7 +7387,7 @@
             <a:off x="11155680" y="20345400"/>
             <a:ext cx="10287000" cy="8412480"/>
           </a:xfrm>
-          <a:prstGeom prst="roundRect">
+          <a:prstGeom prst="rect">
             <a:avLst/>
           </a:prstGeom>
           <a:solidFill>
@@ -7386,7 +7423,7 @@
       </p:sp>
       <p:sp>
         <p:nvSpPr>
-          <p:cNvPr id="90" name="Rectangle 89"/>
+          <p:cNvPr id="91" name="Rectangle 90"/>
           <p:cNvSpPr/>
           <p:nvPr/>
         </p:nvSpPr>
@@ -7429,7 +7466,7 @@
       </p:sp>
       <p:sp>
         <p:nvSpPr>
-          <p:cNvPr id="91" name="Rectangle 90"/>
+          <p:cNvPr id="92" name="Rectangle 91"/>
           <p:cNvSpPr/>
           <p:nvPr/>
         </p:nvSpPr>
@@ -7472,7 +7509,7 @@
       </p:sp>
       <p:sp>
         <p:nvSpPr>
-          <p:cNvPr id="92" name="TextBox 91"/>
+          <p:cNvPr id="93" name="TextBox 92"/>
           <p:cNvSpPr txBox="1"/>
           <p:nvPr/>
         </p:nvSpPr>
@@ -7507,7 +7544,7 @@
       </p:sp>
       <p:sp>
         <p:nvSpPr>
-          <p:cNvPr id="93" name="Rounded Rectangle 92"/>
+          <p:cNvPr id="94" name="Rectangle 93"/>
           <p:cNvSpPr/>
           <p:nvPr/>
         </p:nvSpPr>
@@ -7516,7 +7553,7 @@
             <a:off x="19248120" y="20445984"/>
             <a:ext cx="2011680" cy="347472"/>
           </a:xfrm>
-          <a:prstGeom prst="roundRect">
+          <a:prstGeom prst="rect">
             <a:avLst/>
           </a:prstGeom>
           <a:solidFill>
@@ -7550,7 +7587,7 @@
       </p:sp>
       <p:sp>
         <p:nvSpPr>
-          <p:cNvPr id="94" name="TextBox 93"/>
+          <p:cNvPr id="95" name="TextBox 94"/>
           <p:cNvSpPr txBox="1"/>
           <p:nvPr/>
         </p:nvSpPr>
@@ -7585,7 +7622,7 @@
       </p:sp>
       <p:pic>
         <p:nvPicPr>
-          <p:cNvPr id="95" name="Picture 94" descr="automation_concept.png"/>
+          <p:cNvPr id="96" name="Picture 95" descr="automation_concept.png"/>
           <p:cNvPicPr>
             <a:picLocks noChangeAspect="1"/>
           </p:cNvPicPr>
@@ -7609,7 +7646,7 @@
       </p:pic>
       <p:sp>
         <p:nvSpPr>
-          <p:cNvPr id="96" name="TextBox 95"/>
+          <p:cNvPr id="97" name="TextBox 96"/>
           <p:cNvSpPr txBox="1"/>
           <p:nvPr/>
         </p:nvSpPr>

</xml_diff>